<commit_message>
Documentation updates. Also rmoved SNAPSHOT from the version number.
</commit_message>
<xml_diff>
--- a/doc/UserGuide/includes/illustrations.pptx
+++ b/doc/UserGuide/includes/illustrations.pptx
@@ -211,7 +211,7 @@
             <a:fld id="{BF2392DE-DA90-C84F-9F23-E5C230D67501}" type="datetimeFigureOut">
               <a:rPr lang="en-US" smtClean="0"/>
               <a:pPr/>
-              <a:t>6/16/26</a:t>
+              <a:t>10/8/26</a:t>
             </a:fld>
             <a:endParaRPr lang="en-US"/>
           </a:p>
@@ -1064,7 +1064,7 @@
             <a:fld id="{08BFD309-D479-A847-B915-D65BB723EE4C}" type="datetimeFigureOut">
               <a:rPr lang="en-US" smtClean="0"/>
               <a:pPr/>
-              <a:t>6/16/26</a:t>
+              <a:t>10/8/26</a:t>
             </a:fld>
             <a:endParaRPr lang="en-US"/>
           </a:p>
@@ -1229,7 +1229,7 @@
             <a:fld id="{08BFD309-D479-A847-B915-D65BB723EE4C}" type="datetimeFigureOut">
               <a:rPr lang="en-US" smtClean="0"/>
               <a:pPr/>
-              <a:t>6/16/26</a:t>
+              <a:t>10/8/26</a:t>
             </a:fld>
             <a:endParaRPr lang="en-US"/>
           </a:p>
@@ -1404,7 +1404,7 @@
             <a:fld id="{08BFD309-D479-A847-B915-D65BB723EE4C}" type="datetimeFigureOut">
               <a:rPr lang="en-US" smtClean="0"/>
               <a:pPr/>
-              <a:t>6/16/26</a:t>
+              <a:t>10/8/26</a:t>
             </a:fld>
             <a:endParaRPr lang="en-US"/>
           </a:p>
@@ -1733,7 +1733,7 @@
             <a:fld id="{08BFD309-D479-A847-B915-D65BB723EE4C}" type="datetimeFigureOut">
               <a:rPr lang="en-US" smtClean="0"/>
               <a:pPr/>
-              <a:t>6/16/26</a:t>
+              <a:t>10/8/26</a:t>
             </a:fld>
             <a:endParaRPr lang="en-US"/>
           </a:p>
@@ -1975,7 +1975,7 @@
             <a:fld id="{08BFD309-D479-A847-B915-D65BB723EE4C}" type="datetimeFigureOut">
               <a:rPr lang="en-US" smtClean="0"/>
               <a:pPr/>
-              <a:t>6/16/26</a:t>
+              <a:t>10/8/26</a:t>
             </a:fld>
             <a:endParaRPr lang="en-US"/>
           </a:p>
@@ -2257,7 +2257,7 @@
             <a:fld id="{08BFD309-D479-A847-B915-D65BB723EE4C}" type="datetimeFigureOut">
               <a:rPr lang="en-US" smtClean="0"/>
               <a:pPr/>
-              <a:t>6/16/26</a:t>
+              <a:t>10/8/26</a:t>
             </a:fld>
             <a:endParaRPr lang="en-US"/>
           </a:p>
@@ -2673,7 +2673,7 @@
             <a:fld id="{08BFD309-D479-A847-B915-D65BB723EE4C}" type="datetimeFigureOut">
               <a:rPr lang="en-US" smtClean="0"/>
               <a:pPr/>
-              <a:t>6/16/26</a:t>
+              <a:t>10/8/26</a:t>
             </a:fld>
             <a:endParaRPr lang="en-US"/>
           </a:p>
@@ -2787,7 +2787,7 @@
             <a:fld id="{08BFD309-D479-A847-B915-D65BB723EE4C}" type="datetimeFigureOut">
               <a:rPr lang="en-US" smtClean="0"/>
               <a:pPr/>
-              <a:t>6/16/26</a:t>
+              <a:t>10/8/26</a:t>
             </a:fld>
             <a:endParaRPr lang="en-US"/>
           </a:p>
@@ -2879,7 +2879,7 @@
             <a:fld id="{08BFD309-D479-A847-B915-D65BB723EE4C}" type="datetimeFigureOut">
               <a:rPr lang="en-US" smtClean="0"/>
               <a:pPr/>
-              <a:t>6/16/26</a:t>
+              <a:t>10/8/26</a:t>
             </a:fld>
             <a:endParaRPr lang="en-US"/>
           </a:p>
@@ -3151,7 +3151,7 @@
             <a:fld id="{08BFD309-D479-A847-B915-D65BB723EE4C}" type="datetimeFigureOut">
               <a:rPr lang="en-US" smtClean="0"/>
               <a:pPr/>
-              <a:t>6/16/26</a:t>
+              <a:t>10/8/26</a:t>
             </a:fld>
             <a:endParaRPr lang="en-US"/>
           </a:p>
@@ -3400,7 +3400,7 @@
             <a:fld id="{08BFD309-D479-A847-B915-D65BB723EE4C}" type="datetimeFigureOut">
               <a:rPr lang="en-US" smtClean="0"/>
               <a:pPr/>
-              <a:t>6/16/26</a:t>
+              <a:t>10/8/26</a:t>
             </a:fld>
             <a:endParaRPr lang="en-US"/>
           </a:p>
@@ -3608,7 +3608,7 @@
             <a:fld id="{08BFD309-D479-A847-B915-D65BB723EE4C}" type="datetimeFigureOut">
               <a:rPr lang="en-US" smtClean="0"/>
               <a:pPr/>
-              <a:t>6/16/26</a:t>
+              <a:t>10/8/26</a:t>
             </a:fld>
             <a:endParaRPr lang="en-US"/>
           </a:p>
@@ -5498,7 +5498,7 @@
         </p:nvSpPr>
         <p:spPr bwMode="auto">
           <a:xfrm>
-            <a:off x="2514600" y="3886200"/>
+            <a:off x="2514600" y="3276599"/>
             <a:ext cx="3810000" cy="609600"/>
           </a:xfrm>
           <a:prstGeom prst="rect">
@@ -5564,7 +5564,7 @@
         </p:nvSpPr>
         <p:spPr bwMode="auto">
           <a:xfrm>
-            <a:off x="2514600" y="2057400"/>
+            <a:off x="2514600" y="2057399"/>
             <a:ext cx="3810000" cy="381000"/>
           </a:xfrm>
           <a:prstGeom prst="rect">
@@ -5606,7 +5606,7 @@
                   <a:schemeClr val="tx1"/>
                 </a:solidFill>
               </a:rPr>
-              <a:t>Web Interface</a:t>
+              <a:t>REST Interface</a:t>
             </a:r>
           </a:p>
         </p:txBody>
@@ -5621,7 +5621,7 @@
         </p:nvSpPr>
         <p:spPr bwMode="auto">
           <a:xfrm>
-            <a:off x="2514600" y="2743200"/>
+            <a:off x="2514600" y="2438399"/>
             <a:ext cx="3810000" cy="838200"/>
           </a:xfrm>
           <a:prstGeom prst="rect">
@@ -5665,7 +5665,7 @@
       </p:sp>
       <p:sp>
         <p:nvSpPr>
-          <p:cNvPr id="475153" name="Rectangle 17" descr="Wide upward diagonal"/>
+          <p:cNvPr id="475162" name="Rectangle 26" descr="Wide upward diagonal"/>
           <p:cNvSpPr>
             <a:spLocks noChangeArrowheads="1"/>
           </p:cNvSpPr>
@@ -5673,8 +5673,8 @@
         </p:nvSpPr>
         <p:spPr bwMode="auto">
           <a:xfrm>
-            <a:off x="2514600" y="3581400"/>
-            <a:ext cx="3810000" cy="304800"/>
+            <a:off x="4876800" y="3428999"/>
+            <a:ext cx="1371600" cy="304800"/>
           </a:xfrm>
           <a:prstGeom prst="rect">
             <a:avLst/>
@@ -5704,11 +5704,76 @@
           </a:bodyPr>
           <a:lstStyle/>
           <a:p>
-            <a:r>
-              <a:rPr lang="en-US" sz="1400" dirty="0"/>
-              <a:t>Storage Adapter</a:t>
-            </a:r>
-            <a:endParaRPr lang="en-US" sz="1400" b="0" dirty="0">
+            <a:pPr algn="ctr" eaLnBrk="1" hangingPunct="1">
+              <a:lnSpc>
+                <a:spcPct val="100000"/>
+              </a:lnSpc>
+            </a:pPr>
+            <a:r>
+              <a:rPr lang="en-US" sz="1400" b="0" dirty="0">
+                <a:solidFill>
+                  <a:schemeClr val="tx1"/>
+                </a:solidFill>
+              </a:rPr>
+              <a:t>Rule Engine</a:t>
+            </a:r>
+          </a:p>
+        </p:txBody>
+      </p:sp>
+      <p:sp>
+        <p:nvSpPr>
+          <p:cNvPr id="29" name="Rectangle 27"/>
+          <p:cNvSpPr>
+            <a:spLocks noChangeArrowheads="1"/>
+          </p:cNvSpPr>
+          <p:nvPr/>
+        </p:nvSpPr>
+        <p:spPr bwMode="auto">
+          <a:xfrm>
+            <a:off x="2514600" y="3886199"/>
+            <a:ext cx="3810000" cy="381000"/>
+          </a:xfrm>
+          <a:prstGeom prst="rect">
+            <a:avLst/>
+          </a:prstGeom>
+          <a:solidFill>
+            <a:schemeClr val="bg1">
+              <a:lumMod val="75000"/>
+            </a:schemeClr>
+          </a:solidFill>
+          <a:ln w="9525">
+            <a:solidFill>
+              <a:schemeClr val="tx1"/>
+            </a:solidFill>
+            <a:miter lim="800000"/>
+            <a:headEnd/>
+            <a:tailEnd/>
+          </a:ln>
+          <a:effectLst/>
+        </p:spPr>
+        <p:txBody>
+          <a:bodyPr vert="horz" wrap="square" lIns="91440" anchor="t" anchorCtr="0">
+            <a:prstTxWarp prst="textNoShape">
+              <a:avLst/>
+            </a:prstTxWarp>
+            <a:noAutofit/>
+          </a:bodyPr>
+          <a:lstStyle/>
+          <a:p>
+            <a:pPr eaLnBrk="1" hangingPunct="1">
+              <a:lnSpc>
+                <a:spcPct val="100000"/>
+              </a:lnSpc>
+            </a:pPr>
+            <a:r>
+              <a:rPr lang="en-US" sz="1400" b="0" dirty="0">
+                <a:solidFill>
+                  <a:schemeClr val="tx1"/>
+                </a:solidFill>
+              </a:rPr>
+              <a:t>Operating System</a:t>
+            </a:r>
+            <a:endParaRPr lang="en-US" sz="1400" b="0" baseline="30000" dirty="0">
               <a:solidFill>
                 <a:schemeClr val="tx1"/>
               </a:solidFill>
@@ -5718,7 +5783,7 @@
       </p:sp>
       <p:sp>
         <p:nvSpPr>
-          <p:cNvPr id="475162" name="Rectangle 26" descr="Wide upward diagonal"/>
+          <p:cNvPr id="475163" name="Rectangle 27"/>
           <p:cNvSpPr>
             <a:spLocks noChangeArrowheads="1"/>
           </p:cNvSpPr>
@@ -5726,8 +5791,69 @@
         </p:nvSpPr>
         <p:spPr bwMode="auto">
           <a:xfrm>
-            <a:off x="4876800" y="4038600"/>
+            <a:off x="4876800" y="3886199"/>
             <a:ext cx="1371600" cy="304800"/>
+          </a:xfrm>
+          <a:prstGeom prst="rect">
+            <a:avLst/>
+          </a:prstGeom>
+          <a:solidFill>
+            <a:schemeClr val="bg1">
+              <a:lumMod val="75000"/>
+            </a:schemeClr>
+          </a:solidFill>
+          <a:ln w="9525">
+            <a:solidFill>
+              <a:schemeClr val="tx1"/>
+            </a:solidFill>
+            <a:miter lim="800000"/>
+            <a:headEnd/>
+            <a:tailEnd/>
+          </a:ln>
+          <a:effectLst/>
+        </p:spPr>
+        <p:txBody>
+          <a:bodyPr vert="horz" wrap="square" lIns="91440" anchor="t" anchorCtr="0">
+            <a:prstTxWarp prst="textNoShape">
+              <a:avLst/>
+            </a:prstTxWarp>
+            <a:noAutofit/>
+          </a:bodyPr>
+          <a:lstStyle/>
+          <a:p>
+            <a:pPr algn="ctr" eaLnBrk="1" hangingPunct="1">
+              <a:lnSpc>
+                <a:spcPct val="100000"/>
+              </a:lnSpc>
+            </a:pPr>
+            <a:r>
+              <a:rPr lang="en-US" sz="1400" b="0" dirty="0" err="1">
+                <a:solidFill>
+                  <a:schemeClr val="tx1"/>
+                </a:solidFill>
+              </a:rPr>
+              <a:t>RocksDB</a:t>
+            </a:r>
+            <a:endParaRPr lang="en-US" sz="1400" b="0" baseline="30000" dirty="0">
+              <a:solidFill>
+                <a:schemeClr val="tx1"/>
+              </a:solidFill>
+            </a:endParaRPr>
+          </a:p>
+        </p:txBody>
+      </p:sp>
+      <p:sp>
+        <p:nvSpPr>
+          <p:cNvPr id="33" name="Rectangle 17" descr="Wide upward diagonal"/>
+          <p:cNvSpPr>
+            <a:spLocks noChangeArrowheads="1"/>
+          </p:cNvSpPr>
+          <p:nvPr/>
+        </p:nvSpPr>
+        <p:spPr bwMode="auto">
+          <a:xfrm>
+            <a:off x="2514600" y="2971799"/>
+            <a:ext cx="1524000" cy="304800"/>
           </a:xfrm>
           <a:prstGeom prst="rect">
             <a:avLst/>
@@ -5757,76 +5883,11 @@
           </a:bodyPr>
           <a:lstStyle/>
           <a:p>
-            <a:pPr algn="ctr" eaLnBrk="1" hangingPunct="1">
-              <a:lnSpc>
-                <a:spcPct val="100000"/>
-              </a:lnSpc>
-            </a:pPr>
-            <a:r>
-              <a:rPr lang="en-US" sz="1400" b="0" dirty="0">
-                <a:solidFill>
-                  <a:schemeClr val="tx1"/>
-                </a:solidFill>
-              </a:rPr>
-              <a:t>Rule Engine</a:t>
-            </a:r>
-          </a:p>
-        </p:txBody>
-      </p:sp>
-      <p:sp>
-        <p:nvSpPr>
-          <p:cNvPr id="29" name="Rectangle 27"/>
-          <p:cNvSpPr>
-            <a:spLocks noChangeArrowheads="1"/>
-          </p:cNvSpPr>
-          <p:nvPr/>
-        </p:nvSpPr>
-        <p:spPr bwMode="auto">
-          <a:xfrm>
-            <a:off x="2514600" y="4495800"/>
-            <a:ext cx="3810000" cy="381000"/>
-          </a:xfrm>
-          <a:prstGeom prst="rect">
-            <a:avLst/>
-          </a:prstGeom>
-          <a:solidFill>
-            <a:schemeClr val="bg1">
-              <a:lumMod val="75000"/>
-            </a:schemeClr>
-          </a:solidFill>
-          <a:ln w="9525">
-            <a:solidFill>
-              <a:schemeClr val="tx1"/>
-            </a:solidFill>
-            <a:miter lim="800000"/>
-            <a:headEnd/>
-            <a:tailEnd/>
-          </a:ln>
-          <a:effectLst/>
-        </p:spPr>
-        <p:txBody>
-          <a:bodyPr vert="horz" wrap="square" lIns="91440" anchor="t" anchorCtr="0">
-            <a:prstTxWarp prst="textNoShape">
-              <a:avLst/>
-            </a:prstTxWarp>
-            <a:noAutofit/>
-          </a:bodyPr>
-          <a:lstStyle/>
-          <a:p>
-            <a:pPr eaLnBrk="1" hangingPunct="1">
-              <a:lnSpc>
-                <a:spcPct val="100000"/>
-              </a:lnSpc>
-            </a:pPr>
-            <a:r>
-              <a:rPr lang="en-US" sz="1400" b="0" dirty="0">
-                <a:solidFill>
-                  <a:schemeClr val="tx1"/>
-                </a:solidFill>
-              </a:rPr>
-              <a:t>Operating System</a:t>
-            </a:r>
-            <a:endParaRPr lang="en-US" sz="1400" b="0" baseline="30000" dirty="0">
+            <a:r>
+              <a:rPr lang="en-US" sz="1400" dirty="0"/>
+              <a:t>Index Adapter</a:t>
+            </a:r>
+            <a:endParaRPr lang="en-US" sz="1400" b="0" dirty="0">
               <a:solidFill>
                 <a:schemeClr val="tx1"/>
               </a:solidFill>
@@ -5836,7 +5897,7 @@
       </p:sp>
       <p:sp>
         <p:nvSpPr>
-          <p:cNvPr id="475163" name="Rectangle 27"/>
+          <p:cNvPr id="35" name="Rectangle 17" descr="Wide upward diagonal"/>
           <p:cNvSpPr>
             <a:spLocks noChangeArrowheads="1"/>
           </p:cNvSpPr>
@@ -5844,69 +5905,8 @@
         </p:nvSpPr>
         <p:spPr bwMode="auto">
           <a:xfrm>
-            <a:off x="4876800" y="4495800"/>
-            <a:ext cx="1371600" cy="304800"/>
-          </a:xfrm>
-          <a:prstGeom prst="rect">
-            <a:avLst/>
-          </a:prstGeom>
-          <a:solidFill>
-            <a:schemeClr val="bg1">
-              <a:lumMod val="75000"/>
-            </a:schemeClr>
-          </a:solidFill>
-          <a:ln w="9525">
-            <a:solidFill>
-              <a:schemeClr val="tx1"/>
-            </a:solidFill>
-            <a:miter lim="800000"/>
-            <a:headEnd/>
-            <a:tailEnd/>
-          </a:ln>
-          <a:effectLst/>
-        </p:spPr>
-        <p:txBody>
-          <a:bodyPr vert="horz" wrap="square" lIns="91440" anchor="t" anchorCtr="0">
-            <a:prstTxWarp prst="textNoShape">
-              <a:avLst/>
-            </a:prstTxWarp>
-            <a:noAutofit/>
-          </a:bodyPr>
-          <a:lstStyle/>
-          <a:p>
-            <a:pPr algn="ctr" eaLnBrk="1" hangingPunct="1">
-              <a:lnSpc>
-                <a:spcPct val="100000"/>
-              </a:lnSpc>
-            </a:pPr>
-            <a:r>
-              <a:rPr lang="en-US" sz="1400" b="0" dirty="0" err="1">
-                <a:solidFill>
-                  <a:schemeClr val="tx1"/>
-                </a:solidFill>
-              </a:rPr>
-              <a:t>RocksDB</a:t>
-            </a:r>
-            <a:endParaRPr lang="en-US" sz="1400" b="0" baseline="30000" dirty="0">
-              <a:solidFill>
-                <a:schemeClr val="tx1"/>
-              </a:solidFill>
-            </a:endParaRPr>
-          </a:p>
-        </p:txBody>
-      </p:sp>
-      <p:sp>
-        <p:nvSpPr>
-          <p:cNvPr id="33" name="Rectangle 17" descr="Wide upward diagonal"/>
-          <p:cNvSpPr>
-            <a:spLocks noChangeArrowheads="1"/>
-          </p:cNvSpPr>
-          <p:nvPr/>
-        </p:nvSpPr>
-        <p:spPr bwMode="auto">
-          <a:xfrm>
-            <a:off x="2514600" y="3276600"/>
-            <a:ext cx="1524000" cy="304800"/>
+            <a:off x="1219200" y="2438399"/>
+            <a:ext cx="990600" cy="533400"/>
           </a:xfrm>
           <a:prstGeom prst="rect">
             <a:avLst/>
@@ -5936,21 +5936,25 @@
           </a:bodyPr>
           <a:lstStyle/>
           <a:p>
+            <a:pPr algn="ctr"/>
             <a:r>
               <a:rPr lang="en-US" sz="1400" dirty="0"/>
-              <a:t>Index Adapter</a:t>
-            </a:r>
-            <a:endParaRPr lang="en-US" sz="1400" b="0" dirty="0">
-              <a:solidFill>
-                <a:schemeClr val="tx1"/>
-              </a:solidFill>
-            </a:endParaRPr>
-          </a:p>
-        </p:txBody>
-      </p:sp>
-      <p:sp>
-        <p:nvSpPr>
-          <p:cNvPr id="34" name="Rectangle 17" descr="Wide upward diagonal"/>
+              <a:t>Geospatial </a:t>
+            </a:r>
+            <a:r>
+              <a:rPr lang="en-US" sz="1400" b="0" dirty="0">
+                <a:solidFill>
+                  <a:schemeClr val="tx1"/>
+                </a:solidFill>
+              </a:rPr>
+              <a:t>Index</a:t>
+            </a:r>
+          </a:p>
+        </p:txBody>
+      </p:sp>
+      <p:sp>
+        <p:nvSpPr>
+          <p:cNvPr id="36" name="Rectangle 17" descr="Wide upward diagonal"/>
           <p:cNvSpPr>
             <a:spLocks noChangeArrowheads="1"/>
           </p:cNvSpPr>
@@ -5958,8 +5962,8 @@
         </p:nvSpPr>
         <p:spPr bwMode="auto">
           <a:xfrm>
-            <a:off x="2514600" y="2438400"/>
-            <a:ext cx="3810000" cy="304800"/>
+            <a:off x="1219200" y="3047999"/>
+            <a:ext cx="990600" cy="533400"/>
           </a:xfrm>
           <a:prstGeom prst="rect">
             <a:avLst/>
@@ -5989,132 +5993,18 @@
           </a:bodyPr>
           <a:lstStyle/>
           <a:p>
-            <a:pPr eaLnBrk="1" hangingPunct="1">
-              <a:lnSpc>
-                <a:spcPct val="100000"/>
-              </a:lnSpc>
-            </a:pPr>
+            <a:pPr algn="ctr"/>
+            <a:r>
+              <a:rPr lang="en-US" sz="1400" dirty="0"/>
+              <a:t>Temporal </a:t>
+            </a:r>
             <a:r>
               <a:rPr lang="en-US" sz="1400" b="0" dirty="0">
                 <a:solidFill>
                   <a:schemeClr val="tx1"/>
                 </a:solidFill>
               </a:rPr>
-              <a:t>Named Graph Support</a:t>
-            </a:r>
-          </a:p>
-        </p:txBody>
-      </p:sp>
-      <p:sp>
-        <p:nvSpPr>
-          <p:cNvPr id="35" name="Rectangle 17" descr="Wide upward diagonal"/>
-          <p:cNvSpPr>
-            <a:spLocks noChangeArrowheads="1"/>
-          </p:cNvSpPr>
-          <p:nvPr/>
-        </p:nvSpPr>
-        <p:spPr bwMode="auto">
-          <a:xfrm>
-            <a:off x="1219200" y="2743200"/>
-            <a:ext cx="990600" cy="533400"/>
-          </a:xfrm>
-          <a:prstGeom prst="rect">
-            <a:avLst/>
-          </a:prstGeom>
-          <a:solidFill>
-            <a:schemeClr val="accent1">
-              <a:lumMod val="60000"/>
-              <a:lumOff val="40000"/>
-            </a:schemeClr>
-          </a:solidFill>
-          <a:ln w="9525">
-            <a:solidFill>
-              <a:schemeClr val="tx1"/>
-            </a:solidFill>
-            <a:miter lim="800000"/>
-            <a:headEnd/>
-            <a:tailEnd/>
-          </a:ln>
-          <a:effectLst/>
-        </p:spPr>
-        <p:txBody>
-          <a:bodyPr vert="horz" wrap="square" lIns="91440" anchor="t" anchorCtr="0">
-            <a:prstTxWarp prst="textNoShape">
-              <a:avLst/>
-            </a:prstTxWarp>
-            <a:noAutofit/>
-          </a:bodyPr>
-          <a:lstStyle/>
-          <a:p>
-            <a:pPr algn="ctr" eaLnBrk="1" hangingPunct="1">
-              <a:lnSpc>
-                <a:spcPct val="100000"/>
-              </a:lnSpc>
-            </a:pPr>
-            <a:r>
-              <a:rPr lang="en-US" sz="1400" b="0" dirty="0">
-                <a:solidFill>
-                  <a:schemeClr val="tx1"/>
-                </a:solidFill>
-              </a:rPr>
-              <a:t>Temporal Index</a:t>
-            </a:r>
-          </a:p>
-        </p:txBody>
-      </p:sp>
-      <p:sp>
-        <p:nvSpPr>
-          <p:cNvPr id="36" name="Rectangle 17" descr="Wide upward diagonal"/>
-          <p:cNvSpPr>
-            <a:spLocks noChangeArrowheads="1"/>
-          </p:cNvSpPr>
-          <p:nvPr/>
-        </p:nvSpPr>
-        <p:spPr bwMode="auto">
-          <a:xfrm>
-            <a:off x="1219200" y="3352800"/>
-            <a:ext cx="990600" cy="533400"/>
-          </a:xfrm>
-          <a:prstGeom prst="rect">
-            <a:avLst/>
-          </a:prstGeom>
-          <a:solidFill>
-            <a:schemeClr val="accent1">
-              <a:lumMod val="60000"/>
-              <a:lumOff val="40000"/>
-            </a:schemeClr>
-          </a:solidFill>
-          <a:ln w="9525">
-            <a:solidFill>
-              <a:schemeClr val="tx1"/>
-            </a:solidFill>
-            <a:miter lim="800000"/>
-            <a:headEnd/>
-            <a:tailEnd/>
-          </a:ln>
-          <a:effectLst/>
-        </p:spPr>
-        <p:txBody>
-          <a:bodyPr vert="horz" wrap="square" lIns="91440" anchor="t" anchorCtr="0">
-            <a:prstTxWarp prst="textNoShape">
-              <a:avLst/>
-            </a:prstTxWarp>
-            <a:noAutofit/>
-          </a:bodyPr>
-          <a:lstStyle/>
-          <a:p>
-            <a:pPr algn="ctr" eaLnBrk="1" hangingPunct="1">
-              <a:lnSpc>
-                <a:spcPct val="100000"/>
-              </a:lnSpc>
-            </a:pPr>
-            <a:r>
-              <a:rPr lang="en-US" sz="1400" b="0" dirty="0">
-                <a:solidFill>
-                  <a:schemeClr val="tx1"/>
-                </a:solidFill>
-              </a:rPr>
-              <a:t>Geospatial Index</a:t>
+              <a:t>Index</a:t>
             </a:r>
           </a:p>
         </p:txBody>
@@ -6130,7 +6020,7 @@
         </p:nvCxnSpPr>
         <p:spPr>
           <a:xfrm rot="10800000" flipV="1">
-            <a:off x="2209800" y="3429000"/>
+            <a:off x="2209800" y="3124199"/>
             <a:ext cx="304800" cy="190500"/>
           </a:xfrm>
           <a:prstGeom prst="bentConnector3">
@@ -6169,7 +6059,7 @@
         </p:nvCxnSpPr>
         <p:spPr>
           <a:xfrm rot="10800000">
-            <a:off x="2209800" y="3009900"/>
+            <a:off x="2209800" y="2705099"/>
             <a:ext cx="304800" cy="419100"/>
           </a:xfrm>
           <a:prstGeom prst="bentConnector3">
@@ -6285,13 +6175,15 @@
       <p:cxnSp>
         <p:nvCxnSpPr>
           <p:cNvPr id="56" name="Straight Connector 55"/>
-          <p:cNvCxnSpPr/>
+          <p:cNvCxnSpPr>
+            <a:cxnSpLocks/>
+          </p:cNvCxnSpPr>
           <p:nvPr/>
         </p:nvCxnSpPr>
         <p:spPr>
           <a:xfrm>
-            <a:off x="6400800" y="3886200"/>
-            <a:ext cx="914400" cy="0"/>
+            <a:off x="6400800" y="3276599"/>
+            <a:ext cx="731520" cy="0"/>
           </a:xfrm>
           <a:prstGeom prst="line">
             <a:avLst/>
@@ -6321,7 +6213,7 @@
         </p:nvCxnSpPr>
         <p:spPr>
           <a:xfrm flipV="1">
-            <a:off x="6553200" y="2895600"/>
+            <a:off x="6553200" y="2285999"/>
             <a:ext cx="0" cy="914400"/>
           </a:xfrm>
           <a:prstGeom prst="straightConnector1">
@@ -6355,7 +6247,7 @@
         </p:nvCxnSpPr>
         <p:spPr>
           <a:xfrm flipH="1">
-            <a:off x="6553200" y="3962400"/>
+            <a:off x="6553200" y="3352799"/>
             <a:ext cx="1588" cy="914400"/>
           </a:xfrm>
           <a:prstGeom prst="straightConnector1">
@@ -6389,8 +6281,8 @@
         </p:nvSpPr>
         <p:spPr>
           <a:xfrm>
-            <a:off x="6553200" y="3886200"/>
-            <a:ext cx="762000" cy="457200"/>
+            <a:off x="6553200" y="3276599"/>
+            <a:ext cx="609597" cy="457200"/>
           </a:xfrm>
           <a:prstGeom prst="rect">
             <a:avLst/>
@@ -6418,13 +6310,16 @@
         </p:nvSpPr>
         <p:spPr>
           <a:xfrm>
-            <a:off x="6553200" y="3429000"/>
-            <a:ext cx="762000" cy="457200"/>
+            <a:off x="6553201" y="2819399"/>
+            <a:ext cx="609596" cy="457200"/>
           </a:xfrm>
           <a:prstGeom prst="rect">
             <a:avLst/>
           </a:prstGeom>
           <a:noFill/>
+          <a:ln>
+            <a:noFill/>
+          </a:ln>
         </p:spPr>
         <p:txBody>
           <a:bodyPr wrap="square" lIns="91440" tIns="0" rIns="0" bIns="91440" rtlCol="0" anchor="b" anchorCtr="0">
@@ -6578,7 +6473,7 @@
         </p:nvSpPr>
         <p:spPr bwMode="auto">
           <a:xfrm>
-            <a:off x="4876800" y="2819400"/>
+            <a:off x="4876800" y="2514599"/>
             <a:ext cx="1371600" cy="762000"/>
           </a:xfrm>
           <a:prstGeom prst="rect">
@@ -6632,8 +6527,8 @@
         </p:nvSpPr>
         <p:spPr bwMode="auto">
           <a:xfrm>
-            <a:off x="4876800" y="2133600"/>
-            <a:ext cx="1371600" cy="304800"/>
+            <a:off x="4443845" y="2057399"/>
+            <a:ext cx="1880755" cy="384465"/>
           </a:xfrm>
           <a:prstGeom prst="rect">
             <a:avLst/>
@@ -6666,7 +6561,7 @@
             <a:pPr algn="ctr"/>
             <a:r>
               <a:rPr lang="en-US" sz="1400" dirty="0"/>
-              <a:t>Admin Interface</a:t>
+              <a:t>Administrative Web UI</a:t>
             </a:r>
             <a:endParaRPr lang="en-US" sz="1400" b="0" dirty="0">
               <a:solidFill>

</xml_diff>